<commit_message>
Song Ngoc Redraw Logo
</commit_message>
<xml_diff>
--- a/assets/logos/logo-redraw.pptx
+++ b/assets/logos/logo-redraw.pptx
@@ -7,6 +7,7 @@
   <p:sldIdLst>
     <p:sldId id="256" r:id="rId2"/>
     <p:sldId id="257" r:id="rId3"/>
+    <p:sldId id="258" r:id="rId4"/>
   </p:sldIdLst>
   <p:sldSz cx="12192000" cy="6858000"/>
   <p:notesSz cx="6858000" cy="9144000"/>
@@ -260,7 +261,7 @@
           <a:p>
             <a:fld id="{B835D473-280B-4319-A136-C7C4B767A82C}" type="datetimeFigureOut">
               <a:rPr lang="en-US" smtClean="0"/>
-              <a:t>7/14/2026</a:t>
+              <a:t>7/15/2026</a:t>
             </a:fld>
             <a:endParaRPr lang="en-US"/>
           </a:p>
@@ -458,7 +459,7 @@
           <a:p>
             <a:fld id="{B835D473-280B-4319-A136-C7C4B767A82C}" type="datetimeFigureOut">
               <a:rPr lang="en-US" smtClean="0"/>
-              <a:t>7/14/2026</a:t>
+              <a:t>7/15/2026</a:t>
             </a:fld>
             <a:endParaRPr lang="en-US"/>
           </a:p>
@@ -666,7 +667,7 @@
           <a:p>
             <a:fld id="{B835D473-280B-4319-A136-C7C4B767A82C}" type="datetimeFigureOut">
               <a:rPr lang="en-US" smtClean="0"/>
-              <a:t>7/14/2026</a:t>
+              <a:t>7/15/2026</a:t>
             </a:fld>
             <a:endParaRPr lang="en-US"/>
           </a:p>
@@ -864,7 +865,7 @@
           <a:p>
             <a:fld id="{B835D473-280B-4319-A136-C7C4B767A82C}" type="datetimeFigureOut">
               <a:rPr lang="en-US" smtClean="0"/>
-              <a:t>7/14/2026</a:t>
+              <a:t>7/15/2026</a:t>
             </a:fld>
             <a:endParaRPr lang="en-US"/>
           </a:p>
@@ -1139,7 +1140,7 @@
           <a:p>
             <a:fld id="{B835D473-280B-4319-A136-C7C4B767A82C}" type="datetimeFigureOut">
               <a:rPr lang="en-US" smtClean="0"/>
-              <a:t>7/14/2026</a:t>
+              <a:t>7/15/2026</a:t>
             </a:fld>
             <a:endParaRPr lang="en-US"/>
           </a:p>
@@ -1404,7 +1405,7 @@
           <a:p>
             <a:fld id="{B835D473-280B-4319-A136-C7C4B767A82C}" type="datetimeFigureOut">
               <a:rPr lang="en-US" smtClean="0"/>
-              <a:t>7/14/2026</a:t>
+              <a:t>7/15/2026</a:t>
             </a:fld>
             <a:endParaRPr lang="en-US"/>
           </a:p>
@@ -1816,7 +1817,7 @@
           <a:p>
             <a:fld id="{B835D473-280B-4319-A136-C7C4B767A82C}" type="datetimeFigureOut">
               <a:rPr lang="en-US" smtClean="0"/>
-              <a:t>7/14/2026</a:t>
+              <a:t>7/15/2026</a:t>
             </a:fld>
             <a:endParaRPr lang="en-US"/>
           </a:p>
@@ -1957,7 +1958,7 @@
           <a:p>
             <a:fld id="{B835D473-280B-4319-A136-C7C4B767A82C}" type="datetimeFigureOut">
               <a:rPr lang="en-US" smtClean="0"/>
-              <a:t>7/14/2026</a:t>
+              <a:t>7/15/2026</a:t>
             </a:fld>
             <a:endParaRPr lang="en-US"/>
           </a:p>
@@ -2070,7 +2071,7 @@
           <a:p>
             <a:fld id="{B835D473-280B-4319-A136-C7C4B767A82C}" type="datetimeFigureOut">
               <a:rPr lang="en-US" smtClean="0"/>
-              <a:t>7/14/2026</a:t>
+              <a:t>7/15/2026</a:t>
             </a:fld>
             <a:endParaRPr lang="en-US"/>
           </a:p>
@@ -2381,7 +2382,7 @@
           <a:p>
             <a:fld id="{B835D473-280B-4319-A136-C7C4B767A82C}" type="datetimeFigureOut">
               <a:rPr lang="en-US" smtClean="0"/>
-              <a:t>7/14/2026</a:t>
+              <a:t>7/15/2026</a:t>
             </a:fld>
             <a:endParaRPr lang="en-US"/>
           </a:p>
@@ -2669,7 +2670,7 @@
           <a:p>
             <a:fld id="{B835D473-280B-4319-A136-C7C4B767A82C}" type="datetimeFigureOut">
               <a:rPr lang="en-US" smtClean="0"/>
-              <a:t>7/14/2026</a:t>
+              <a:t>7/15/2026</a:t>
             </a:fld>
             <a:endParaRPr lang="en-US"/>
           </a:p>
@@ -2910,7 +2911,7 @@
           <a:p>
             <a:fld id="{B835D473-280B-4319-A136-C7C4B767A82C}" type="datetimeFigureOut">
               <a:rPr lang="en-US" smtClean="0"/>
-              <a:t>7/14/2026</a:t>
+              <a:t>7/15/2026</a:t>
             </a:fld>
             <a:endParaRPr lang="en-US"/>
           </a:p>
@@ -3313,6 +3314,40 @@
 <file path=ppt/slides/slide1.xml><?xml version="1.0" encoding="utf-8"?>
 <p:sld xmlns:a="http://schemas.openxmlformats.org/drawingml/2006/main" xmlns:r="http://schemas.openxmlformats.org/officeDocument/2006/relationships" xmlns:p="http://schemas.openxmlformats.org/presentationml/2006/main">
   <p:cSld>
+    <p:bg>
+      <p:bgPr>
+        <a:gradFill>
+          <a:gsLst>
+            <a:gs pos="0">
+              <a:schemeClr val="accent1">
+                <a:lumMod val="5000"/>
+                <a:lumOff val="95000"/>
+              </a:schemeClr>
+            </a:gs>
+            <a:gs pos="74000">
+              <a:schemeClr val="accent1">
+                <a:lumMod val="45000"/>
+                <a:lumOff val="55000"/>
+              </a:schemeClr>
+            </a:gs>
+            <a:gs pos="83000">
+              <a:schemeClr val="accent1">
+                <a:lumMod val="45000"/>
+                <a:lumOff val="55000"/>
+              </a:schemeClr>
+            </a:gs>
+            <a:gs pos="100000">
+              <a:schemeClr val="accent1">
+                <a:lumMod val="30000"/>
+                <a:lumOff val="70000"/>
+              </a:schemeClr>
+            </a:gs>
+          </a:gsLst>
+          <a:lin ang="5400000" scaled="1"/>
+        </a:gradFill>
+        <a:effectLst/>
+      </p:bgPr>
+    </p:bg>
     <p:spTree>
       <p:nvGrpSpPr>
         <p:cNvPr id="1" name=""/>
@@ -3422,13 +3457,13 @@
   <p:clrMapOvr>
     <a:masterClrMapping/>
   </p:clrMapOvr>
-  <mc:AlternateContent xmlns:mc="http://schemas.openxmlformats.org/markup-compatibility/2006">
-    <mc:Choice xmlns:p14="http://schemas.microsoft.com/office/powerpoint/2010/main" Requires="p14">
+  <mc:AlternateContent xmlns:mc="http://schemas.openxmlformats.org/markup-compatibility/2006" xmlns:p14="http://schemas.microsoft.com/office/powerpoint/2010/main">
+    <mc:Choice Requires="p14">
       <p:transition spd="slow" p14:dur="4000">
         <p14:vortex dir="r"/>
       </p:transition>
     </mc:Choice>
-    <mc:Fallback>
+    <mc:Fallback xmlns="">
       <p:transition spd="slow">
         <p:fade/>
       </p:transition>
@@ -3442,8 +3477,102 @@
   <p:cSld>
     <p:bg>
       <p:bgPr>
+        <a:gradFill>
+          <a:gsLst>
+            <a:gs pos="0">
+              <a:srgbClr val="CCFFFF"/>
+            </a:gs>
+            <a:gs pos="100000">
+              <a:schemeClr val="bg1"/>
+            </a:gs>
+          </a:gsLst>
+          <a:lin ang="5400000" scaled="1"/>
+        </a:gradFill>
+        <a:effectLst/>
+      </p:bgPr>
+    </p:bg>
+    <p:spTree>
+      <p:nvGrpSpPr>
+        <p:cNvPr id="1" name=""/>
+        <p:cNvGrpSpPr/>
+        <p:nvPr/>
+      </p:nvGrpSpPr>
+      <p:grpSpPr>
+        <a:xfrm>
+          <a:off x="0" y="0"/>
+          <a:ext cx="0" cy="0"/>
+          <a:chOff x="0" y="0"/>
+          <a:chExt cx="0" cy="0"/>
+        </a:xfrm>
+      </p:grpSpPr>
+      <p:pic>
+        <p:nvPicPr>
+          <p:cNvPr id="3" name="Picture 2">
+            <a:extLst>
+              <a:ext uri="{FF2B5EF4-FFF2-40B4-BE49-F238E27FC236}">
+                <a16:creationId xmlns:a16="http://schemas.microsoft.com/office/drawing/2014/main" id="{4F9160FF-E83C-4FCF-9C8D-C817045C4431}"/>
+              </a:ext>
+            </a:extLst>
+          </p:cNvPr>
+          <p:cNvPicPr>
+            <a:picLocks noChangeAspect="1"/>
+          </p:cNvPicPr>
+          <p:nvPr/>
+        </p:nvPicPr>
+        <p:blipFill>
+          <a:blip r:embed="rId2">
+            <a:extLst>
+              <a:ext uri="{28A0092B-C50C-407E-A947-70E740481C1C}">
+                <a14:useLocalDpi xmlns:a14="http://schemas.microsoft.com/office/drawing/2010/main" val="0"/>
+              </a:ext>
+            </a:extLst>
+          </a:blip>
+          <a:stretch>
+            <a:fillRect/>
+          </a:stretch>
+        </p:blipFill>
+        <p:spPr>
+          <a:xfrm>
+            <a:off x="2485736" y="1712263"/>
+            <a:ext cx="7220527" cy="4061546"/>
+          </a:xfrm>
+          <a:prstGeom prst="rect">
+            <a:avLst/>
+          </a:prstGeom>
+        </p:spPr>
+      </p:pic>
+    </p:spTree>
+    <p:extLst>
+      <p:ext uri="{BB962C8B-B14F-4D97-AF65-F5344CB8AC3E}">
+        <p14:creationId xmlns:p14="http://schemas.microsoft.com/office/powerpoint/2010/main" val="2136525532"/>
+      </p:ext>
+    </p:extLst>
+  </p:cSld>
+  <p:clrMapOvr>
+    <a:masterClrMapping/>
+  </p:clrMapOvr>
+  <mc:AlternateContent xmlns:mc="http://schemas.openxmlformats.org/markup-compatibility/2006" xmlns:p14="http://schemas.microsoft.com/office/powerpoint/2010/main">
+    <mc:Choice Requires="p14">
+      <p:transition spd="slow" p14:dur="4000">
+        <p14:vortex dir="r"/>
+      </p:transition>
+    </mc:Choice>
+    <mc:Fallback xmlns="">
+      <p:transition spd="slow">
+        <p:fade/>
+      </p:transition>
+    </mc:Fallback>
+  </mc:AlternateContent>
+</p:sld>
+</file>
+
+<file path=ppt/slides/slide3.xml><?xml version="1.0" encoding="utf-8"?>
+<p:sld xmlns:a="http://schemas.openxmlformats.org/drawingml/2006/main" xmlns:r="http://schemas.openxmlformats.org/officeDocument/2006/relationships" xmlns:p="http://schemas.openxmlformats.org/presentationml/2006/main">
+  <p:cSld>
+    <p:bg>
+      <p:bgPr>
         <a:solidFill>
-          <a:schemeClr val="bg1"/>
+          <a:srgbClr val="002060"/>
         </a:solidFill>
         <a:effectLst/>
       </p:bgPr>
@@ -3490,7 +3619,7 @@
         </p:blipFill>
         <p:spPr>
           <a:xfrm>
-            <a:off x="2485736" y="1398227"/>
+            <a:off x="2485736" y="1712263"/>
             <a:ext cx="7220527" cy="4061546"/>
           </a:xfrm>
           <a:prstGeom prst="rect">
@@ -3501,7 +3630,7 @@
     </p:spTree>
     <p:extLst>
       <p:ext uri="{BB962C8B-B14F-4D97-AF65-F5344CB8AC3E}">
-        <p14:creationId xmlns:p14="http://schemas.microsoft.com/office/powerpoint/2010/main" val="2136525532"/>
+        <p14:creationId xmlns:p14="http://schemas.microsoft.com/office/powerpoint/2010/main" val="779212225"/>
       </p:ext>
     </p:extLst>
   </p:cSld>

</xml_diff>